<commit_message>
Harden PPT export and multi-template QA
</commit_message>
<xml_diff>
--- a/skills/uav-paper-report/assets/examples/uav-fov-cbf-regression-report.pptx
+++ b/skills/uav-paper-report/assets/examples/uav-fov-cbf-regression-report.pptx
@@ -11369,7 +11369,7 @@
                 <a:ea typeface="Times New Roman"/>
                 <a:cs typeface="Times New Roman"/>
               </a:rPr>
-              <a:t>(6)    </a:t>
+              <a:t>(6)    bₛᵣ(rᵢⱼ) = rᵢⱼ^T rᵢⱼ - Dₛ^2 &gt;= 0</a:t>
             </a:r>
             <a:r>
               <a:rPr sz="2100" b="0">
@@ -11380,7 +11380,7 @@
                 <a:ea typeface="Times New Roman"/>
                 <a:cs typeface="Times New Roman"/>
               </a:rPr>
-              <a:t>b_sr(r_ij) = r_ij^T r_ij - D_s^2 &gt;= 0</a:t>
+              <a:t/>
             </a:r>
           </a:p>
         </p:txBody>
@@ -11427,7 +11427,7 @@
                 <a:ea typeface="Times New Roman"/>
                 <a:cs typeface="Times New Roman"/>
               </a:rPr>
-              <a:t>    </a:t>
+              <a:t>    rᵢⱼ = rⱼ - rᵢ 表示邻居相对位置，Dₛ 是最小安全距离</a:t>
             </a:r>
             <a:r>
               <a:rPr sz="1820" b="0">
@@ -11438,7 +11438,7 @@
                 <a:ea typeface="Times New Roman"/>
                 <a:cs typeface="Times New Roman"/>
               </a:rPr>
-              <a:t>r_ij = r_j - r_i 表示邻居相对位置，D_s 是最小安全距离</a:t>
+              <a:t/>
             </a:r>
           </a:p>
         </p:txBody>
@@ -11532,7 +11532,7 @@
                 <a:ea typeface="Times New Roman"/>
                 <a:cs typeface="Times New Roman"/>
               </a:rPr>
-              <a:t>(7)    </a:t>
+              <a:t>(7)    b𝒇(rᵢⱼ) &gt;= 0 约束邻居位于水平视场角 β(H) 内</a:t>
             </a:r>
             <a:r>
               <a:rPr sz="2000" b="0">
@@ -11543,7 +11543,7 @@
                 <a:ea typeface="Times New Roman"/>
                 <a:cs typeface="Times New Roman"/>
               </a:rPr>
-              <a:t>b_fov(r_ij) &gt;= 0 约束邻居位于水平视场角 β_H 内</a:t>
+              <a:t/>
             </a:r>
           </a:p>
         </p:txBody>
@@ -11590,7 +11590,7 @@
                 <a:ea typeface="Times New Roman"/>
                 <a:cs typeface="Times New Roman"/>
               </a:rPr>
-              <a:t>(8)    </a:t>
+              <a:t>(8)    b(rᵢⱼ) = [ bₛᵣ; b𝒇 ] &gt;= 0,  ∀j∈Nᵢ</a:t>
             </a:r>
             <a:r>
               <a:rPr sz="2000" b="0">
@@ -11601,7 +11601,7 @@
                 <a:ea typeface="Times New Roman"/>
                 <a:cs typeface="Times New Roman"/>
               </a:rPr>
-              <a:t>b(r_ij) = [ b_sr; b_fov ] &gt;= 0,  ∀j∈N_i</a:t>
+              <a:t/>
             </a:r>
           </a:p>
         </p:txBody>
@@ -11672,7 +11672,7 @@
                 <a:ea typeface="Times New Roman"/>
                 <a:cs typeface="Times New Roman"/>
               </a:rPr>
-              <a:t>• b_sr控制邻居间最小距离，防止多机碰撞。</a:t>
+              <a:t>• bₛᵣ控制邻居间最小距离，防止多机碰撞。</a:t>
             </a:r>
           </a:p>
           <a:p>
@@ -11696,7 +11696,7 @@
                 <a:ea typeface="Times New Roman"/>
                 <a:cs typeface="Times New Roman"/>
               </a:rPr>
-              <a:t>• b_fov控制相对方位，保证邻居保持在相机视场内。</a:t>
+              <a:t>• b𝒇控制相对方位，保证邻居保持在相机视场内。</a:t>
             </a:r>
           </a:p>
           <a:p>
@@ -12121,7 +12121,7 @@
                 <a:ea typeface="Times New Roman"/>
                 <a:cs typeface="Times New Roman"/>
               </a:rPr>
-              <a:t>(9)    </a:t>
+              <a:t>(9)    L(f)^2 b(.) + L(g) L(f) b(.) u + (2μ+1)γ₁ b^(2μ)(.) L(f) b(.)</a:t>
             </a:r>
             <a:r>
               <a:rPr sz="1939" b="0">
@@ -12132,7 +12132,7 @@
                 <a:ea typeface="Times New Roman"/>
                 <a:cs typeface="Times New Roman"/>
               </a:rPr>
-              <a:t>L_f^2 b(.) + L_g L_f b(.) u + (2μ+1)γ_1 b^(2μ)(.) L_f b(.)</a:t>
+              <a:t/>
             </a:r>
           </a:p>
         </p:txBody>
@@ -12179,7 +12179,7 @@
                 <a:ea typeface="Times New Roman"/>
                 <a:cs typeface="Times New Roman"/>
               </a:rPr>
-              <a:t>    </a:t>
+              <a:t>    + γ₂( L(f) b(.) + γ₁ b^(2μ+1)(.) )^(2μ+1) &gt;= 0</a:t>
             </a:r>
             <a:r>
               <a:rPr sz="1939" b="0">
@@ -12190,7 +12190,7 @@
                 <a:ea typeface="Times New Roman"/>
                 <a:cs typeface="Times New Roman"/>
               </a:rPr>
-              <a:t>+ γ_2( L_f b(.) + γ_1 b^(2μ+1)(.) )^(2μ+1) &gt;= 0</a:t>
+              <a:t/>
             </a:r>
           </a:p>
         </p:txBody>
@@ -12273,7 +12273,7 @@
                 <a:ea typeface="Times New Roman"/>
                 <a:cs typeface="Times New Roman"/>
               </a:rPr>
-              <a:t>• L_f、L_g表示沿系统动力学的Lie derivative。</a:t>
+              <a:t>• L(f)、L(g)表示沿系统动力学的Lie derivative。</a:t>
             </a:r>
           </a:p>
           <a:p>
@@ -13182,7 +13182,7 @@
                 <a:ea typeface="Times New Roman"/>
                 <a:cs typeface="Times New Roman"/>
               </a:rPr>
-              <a:t>(10a)    </a:t>
+              <a:t>(10a)    min(U)  J꜀</a:t>
             </a:r>
             <a:r>
               <a:rPr sz="2080" b="0">
@@ -13193,7 +13193,7 @@
                 <a:ea typeface="Times New Roman"/>
                 <a:cs typeface="Times New Roman"/>
               </a:rPr>
-              <a:t>min_U  J_cost</a:t>
+              <a:t/>
             </a:r>
           </a:p>
         </p:txBody>
@@ -13240,7 +13240,7 @@
                 <a:ea typeface="Times New Roman"/>
                 <a:cs typeface="Times New Roman"/>
               </a:rPr>
-              <a:t>(10b)    </a:t>
+              <a:t>(10b)    ẋ(t) = A x(t) + B u(t)</a:t>
             </a:r>
             <a:r>
               <a:rPr sz="2000" b="0">
@@ -13251,7 +13251,7 @@
                 <a:ea typeface="Times New Roman"/>
                 <a:cs typeface="Times New Roman"/>
               </a:rPr>
-              <a:t>x_dot(t) = A x(t) + B u(t)</a:t>
+              <a:t/>
             </a:r>
           </a:p>
         </p:txBody>
@@ -13298,7 +13298,7 @@
                 <a:ea typeface="Times New Roman"/>
                 <a:cs typeface="Times New Roman"/>
               </a:rPr>
-              <a:t>(10e)    </a:t>
+              <a:t>(10e)    A꜀ u(t) + b꜀(rᵢⱼ(t|t0)) &gt;= 0</a:t>
             </a:r>
             <a:r>
               <a:rPr sz="1960" b="0">
@@ -13309,7 +13309,7 @@
                 <a:ea typeface="Times New Roman"/>
                 <a:cs typeface="Times New Roman"/>
               </a:rPr>
-              <a:t>A_cbf u(t) + b_cbf(r_ij(t|t0)) &gt;= 0</a:t>
+              <a:t/>
             </a:r>
           </a:p>
         </p:txBody>
@@ -13356,7 +13356,7 @@
                 <a:ea typeface="Times New Roman"/>
                 <a:cs typeface="Times New Roman"/>
               </a:rPr>
-              <a:t>(10f)    </a:t>
+              <a:t>(10f)    aₘᵢₙ &lt;= u(t) &lt;= aₘₐₓ</a:t>
             </a:r>
             <a:r>
               <a:rPr sz="1920" b="0">
@@ -13367,7 +13367,7 @@
                 <a:ea typeface="Times New Roman"/>
                 <a:cs typeface="Times New Roman"/>
               </a:rPr>
-              <a:t>a_min &lt;= u(t) &lt;= a_max</a:t>
+              <a:t/>
             </a:r>
           </a:p>
         </p:txBody>

</xml_diff>

<commit_message>
Tighten paper report layout QA
</commit_message>
<xml_diff>
--- a/skills/uav-paper-report/assets/examples/uav-fov-cbf-regression-report.pptx
+++ b/skills/uav-paper-report/assets/examples/uav-fov-cbf-regression-report.pptx
@@ -11936,284 +11936,25 @@
       </p:pic>
       <p:sp>
         <p:nvSpPr>
-          <p:cNvPr id="4" name="TextBox 3"/>
-          <p:cNvSpPr txBox="1"/>
-          <p:nvPr/>
-        </p:nvSpPr>
-        <p:spPr>
-          <a:xfrm>
-            <a:off x="2971800" y="100584"/>
-            <a:ext cx="7040880" cy="566928"/>
-          </a:xfrm>
-          <a:prstGeom prst="rect">
-            <a:avLst/>
-          </a:prstGeom>
-          <a:noFill/>
-        </p:spPr>
-        <p:txBody>
-          <a:bodyPr wrap="square">
-            <a:spAutoFit/>
-          </a:bodyPr>
-          <a:lstStyle/>
-          <a:p>
-            <a:pPr algn="l"/>
-            <a:r>
-              <a:rPr sz="2800" b="1">
-                <a:solidFill>
-                  <a:srgbClr val="000000"/>
-                </a:solidFill>
-                <a:latin typeface="Times New Roman"/>
-                <a:ea typeface="Times New Roman"/>
-                <a:cs typeface="Times New Roman"/>
-              </a:rPr>
-              <a:t>Part. 02  研究方法</a:t>
-            </a:r>
-          </a:p>
-        </p:txBody>
-      </p:sp>
-      <p:sp>
-        <p:nvSpPr>
-          <p:cNvPr id="5" name="TextBox 4"/>
-          <p:cNvSpPr txBox="1"/>
-          <p:nvPr/>
-        </p:nvSpPr>
-        <p:spPr>
-          <a:xfrm>
-            <a:off x="640080" y="1024128"/>
-            <a:ext cx="7772400" cy="493776"/>
-          </a:xfrm>
-          <a:prstGeom prst="rect">
-            <a:avLst/>
-          </a:prstGeom>
-          <a:noFill/>
-        </p:spPr>
-        <p:txBody>
-          <a:bodyPr wrap="square">
-            <a:spAutoFit/>
-          </a:bodyPr>
-          <a:lstStyle/>
-          <a:p>
-            <a:pPr algn="l"/>
-            <a:r>
-              <a:rPr sz="2000" b="1">
-                <a:solidFill>
-                  <a:srgbClr val="000000"/>
-                </a:solidFill>
-                <a:latin typeface="Times New Roman"/>
-                <a:ea typeface="Times New Roman"/>
-                <a:cs typeface="Times New Roman"/>
-              </a:rPr>
-              <a:t>2.3 高阶 CBF 认证</a:t>
-            </a:r>
-          </a:p>
-        </p:txBody>
-      </p:sp>
-      <p:sp>
-        <p:nvSpPr>
-          <p:cNvPr id="6" name="TextBox 5"/>
-          <p:cNvSpPr txBox="1"/>
-          <p:nvPr/>
-        </p:nvSpPr>
-        <p:spPr>
-          <a:xfrm>
-            <a:off x="566928" y="1609344"/>
-            <a:ext cx="11009376" cy="731520"/>
-          </a:xfrm>
-          <a:prstGeom prst="rect">
-            <a:avLst/>
-          </a:prstGeom>
-          <a:noFill/>
-        </p:spPr>
-        <p:txBody>
-          <a:bodyPr wrap="square" lIns="0" rIns="0" tIns="0" bIns="0">
-            <a:spAutoFit/>
-          </a:bodyPr>
-          <a:lstStyle/>
-          <a:p>
-            <a:pPr algn="l" marL="210000" indent="-140000">
-              <a:lnSpc>
-                <a:spcPct val="96000"/>
-              </a:lnSpc>
-              <a:spcBef>
-                <a:spcPts val="0"/>
-              </a:spcBef>
-              <a:spcAft>
-                <a:spcPts val="2"/>
-              </a:spcAft>
-            </a:pPr>
-            <a:r>
-              <a:rPr sz="1920" b="1">
-                <a:solidFill>
-                  <a:srgbClr val="000000"/>
-                </a:solidFill>
-                <a:latin typeface="Times New Roman"/>
-                <a:ea typeface="Times New Roman"/>
-                <a:cs typeface="Times New Roman"/>
-              </a:rPr>
-              <a:t>● 四旋翼规划采用双积分近似时，FOV/距离约束对控制输入具有相对阶，需要高阶CBF。</a:t>
-            </a:r>
-          </a:p>
-          <a:p>
-            <a:pPr algn="l" marL="350000" indent="-120000">
-              <a:lnSpc>
-                <a:spcPct val="96000"/>
-              </a:lnSpc>
-              <a:spcBef>
-                <a:spcPts val="0"/>
-              </a:spcBef>
-              <a:spcAft>
-                <a:spcPts val="2"/>
-              </a:spcAft>
-            </a:pPr>
-            <a:r>
-              <a:rPr sz="1840" b="0">
-                <a:solidFill>
-                  <a:srgbClr val="000000"/>
-                </a:solidFill>
-                <a:latin typeface="Times New Roman"/>
-                <a:ea typeface="Times New Roman"/>
-                <a:cs typeface="Times New Roman"/>
-              </a:rPr>
-              <a:t>• HOCBF将安全集合前向不变性转化为控制输入u上的可检查不等式。</a:t>
-            </a:r>
-          </a:p>
-        </p:txBody>
-      </p:sp>
-      <p:sp>
-        <p:nvSpPr>
-          <p:cNvPr id="7" name="TextBox 6"/>
-          <p:cNvSpPr txBox="1"/>
-          <p:nvPr/>
-        </p:nvSpPr>
-        <p:spPr>
-          <a:xfrm>
-            <a:off x="841248" y="2743200"/>
-            <a:ext cx="10607040" cy="456102"/>
-          </a:xfrm>
-          <a:prstGeom prst="rect">
-            <a:avLst/>
-          </a:prstGeom>
-          <a:noFill/>
-        </p:spPr>
-        <p:txBody>
-          <a:bodyPr wrap="none" lIns="0" rIns="0" tIns="0" bIns="0">
-            <a:spAutoFit/>
-          </a:bodyPr>
-          <a:lstStyle/>
-          <a:p>
-            <a:pPr algn="l">
-              <a:lnSpc>
-                <a:spcPct val="100000"/>
-              </a:lnSpc>
-              <a:spcBef>
-                <a:spcPts val="0"/>
-              </a:spcBef>
-              <a:spcAft>
-                <a:spcPts val="0"/>
-              </a:spcAft>
-            </a:pPr>
-            <a:r>
-              <a:rPr sz="1939" b="1">
-                <a:solidFill>
-                  <a:srgbClr val="4E4E4E"/>
-                </a:solidFill>
-                <a:latin typeface="Times New Roman"/>
-                <a:ea typeface="Times New Roman"/>
-                <a:cs typeface="Times New Roman"/>
-              </a:rPr>
-              <a:t>(9)    L(f)^2 b(.) + L(g) L(f) b(.) u + (2μ+1)γ₁ b^(2μ)(.) L(f) b(.)</a:t>
-            </a:r>
-            <a:r>
-              <a:rPr sz="1939" b="0">
-                <a:solidFill>
-                  <a:srgbClr val="000000"/>
-                </a:solidFill>
-                <a:latin typeface="Times New Roman"/>
-                <a:ea typeface="Times New Roman"/>
-                <a:cs typeface="Times New Roman"/>
-              </a:rPr>
-              <a:t/>
-            </a:r>
-          </a:p>
-        </p:txBody>
-      </p:sp>
-      <p:sp>
-        <p:nvSpPr>
-          <p:cNvPr id="8" name="TextBox 7"/>
-          <p:cNvSpPr txBox="1"/>
-          <p:nvPr/>
-        </p:nvSpPr>
-        <p:spPr>
-          <a:xfrm>
-            <a:off x="841248" y="3273552"/>
-            <a:ext cx="10607040" cy="456102"/>
-          </a:xfrm>
-          <a:prstGeom prst="rect">
-            <a:avLst/>
-          </a:prstGeom>
-          <a:noFill/>
-        </p:spPr>
-        <p:txBody>
-          <a:bodyPr wrap="none" lIns="0" rIns="0" tIns="0" bIns="0">
-            <a:spAutoFit/>
-          </a:bodyPr>
-          <a:lstStyle/>
-          <a:p>
-            <a:pPr algn="l">
-              <a:lnSpc>
-                <a:spcPct val="100000"/>
-              </a:lnSpc>
-              <a:spcBef>
-                <a:spcPts val="0"/>
-              </a:spcBef>
-              <a:spcAft>
-                <a:spcPts val="0"/>
-              </a:spcAft>
-            </a:pPr>
-            <a:r>
-              <a:rPr sz="1939" b="1">
-                <a:solidFill>
-                  <a:srgbClr val="4E4E4E"/>
-                </a:solidFill>
-                <a:latin typeface="Times New Roman"/>
-                <a:ea typeface="Times New Roman"/>
-                <a:cs typeface="Times New Roman"/>
-              </a:rPr>
-              <a:t>    + γ₂( L(f) b(.) + γ₁ b^(2μ+1)(.) )^(2μ+1) &gt;= 0</a:t>
-            </a:r>
-            <a:r>
-              <a:rPr sz="1939" b="0">
-                <a:solidFill>
-                  <a:srgbClr val="000000"/>
-                </a:solidFill>
-                <a:latin typeface="Times New Roman"/>
-                <a:ea typeface="Times New Roman"/>
-                <a:cs typeface="Times New Roman"/>
-              </a:rPr>
-              <a:t/>
-            </a:r>
-          </a:p>
-        </p:txBody>
-      </p:sp>
-      <p:sp>
-        <p:nvSpPr>
-          <p:cNvPr id="9" name="Rectangle 8"/>
+          <p:cNvPr id="12" name="DENSITY_FORMULA_PANEL"/>
           <p:cNvSpPr/>
           <p:nvPr/>
         </p:nvSpPr>
         <p:spPr>
           <a:xfrm>
-            <a:off x="694944" y="4096512"/>
-            <a:ext cx="10789920" cy="16459"/>
+            <a:off x="713232" y="2304288"/>
+            <a:ext cx="10771632" cy="1152144"/>
           </a:xfrm>
           <a:prstGeom prst="rect">
             <a:avLst/>
           </a:prstGeom>
           <a:solidFill>
-            <a:srgbClr val="BEBEBE"/>
+            <a:srgbClr val="F2F4F7"/>
           </a:solidFill>
-          <a:ln>
-            <a:noFill/>
+          <a:ln w="8890">
+            <a:solidFill>
+              <a:srgbClr val="D6DAE0"/>
+            </a:solidFill>
           </a:ln>
         </p:spPr>
         <p:style>
@@ -12233,14 +11974,88 @@
       </p:sp>
       <p:sp>
         <p:nvSpPr>
-          <p:cNvPr id="10" name="TextBox 9"/>
+          <p:cNvPr id="4" name="TextBox 3"/>
           <p:cNvSpPr txBox="1"/>
           <p:nvPr/>
         </p:nvSpPr>
         <p:spPr>
           <a:xfrm>
-            <a:off x="676656" y="4334256"/>
-            <a:ext cx="5266944" cy="1517904"/>
+            <a:off x="2971800" y="100584"/>
+            <a:ext cx="7040880" cy="566928"/>
+          </a:xfrm>
+          <a:prstGeom prst="rect">
+            <a:avLst/>
+          </a:prstGeom>
+          <a:noFill/>
+        </p:spPr>
+        <p:txBody>
+          <a:bodyPr wrap="square">
+            <a:spAutoFit/>
+          </a:bodyPr>
+          <a:lstStyle/>
+          <a:p>
+            <a:pPr algn="l"/>
+            <a:r>
+              <a:rPr sz="2800" b="1">
+                <a:solidFill>
+                  <a:srgbClr val="000000"/>
+                </a:solidFill>
+                <a:latin typeface="Times New Roman"/>
+                <a:ea typeface="Times New Roman"/>
+                <a:cs typeface="Times New Roman"/>
+              </a:rPr>
+              <a:t>Part. 02  研究方法</a:t>
+            </a:r>
+          </a:p>
+        </p:txBody>
+      </p:sp>
+      <p:sp>
+        <p:nvSpPr>
+          <p:cNvPr id="5" name="TextBox 4"/>
+          <p:cNvSpPr txBox="1"/>
+          <p:nvPr/>
+        </p:nvSpPr>
+        <p:spPr>
+          <a:xfrm>
+            <a:off x="640080" y="1024128"/>
+            <a:ext cx="7772400" cy="493776"/>
+          </a:xfrm>
+          <a:prstGeom prst="rect">
+            <a:avLst/>
+          </a:prstGeom>
+          <a:noFill/>
+        </p:spPr>
+        <p:txBody>
+          <a:bodyPr wrap="square">
+            <a:spAutoFit/>
+          </a:bodyPr>
+          <a:lstStyle/>
+          <a:p>
+            <a:pPr algn="l"/>
+            <a:r>
+              <a:rPr sz="2000" b="1">
+                <a:solidFill>
+                  <a:srgbClr val="000000"/>
+                </a:solidFill>
+                <a:latin typeface="Times New Roman"/>
+                <a:ea typeface="Times New Roman"/>
+                <a:cs typeface="Times New Roman"/>
+              </a:rPr>
+              <a:t>2.3 高阶 CBF 认证</a:t>
+            </a:r>
+          </a:p>
+        </p:txBody>
+      </p:sp>
+      <p:sp>
+        <p:nvSpPr>
+          <p:cNvPr id="6" name="TextBox 5"/>
+          <p:cNvSpPr txBox="1"/>
+          <p:nvPr/>
+        </p:nvSpPr>
+        <p:spPr>
+          <a:xfrm>
+            <a:off x="566928" y="1609344"/>
+            <a:ext cx="11009376" cy="731520"/>
           </a:xfrm>
           <a:prstGeom prst="rect">
             <a:avLst/>
@@ -12253,6 +12068,229 @@
           </a:bodyPr>
           <a:lstStyle/>
           <a:p>
+            <a:pPr algn="l" marL="210000" indent="-140000">
+              <a:lnSpc>
+                <a:spcPct val="96000"/>
+              </a:lnSpc>
+              <a:spcBef>
+                <a:spcPts val="0"/>
+              </a:spcBef>
+              <a:spcAft>
+                <a:spcPts val="2"/>
+              </a:spcAft>
+            </a:pPr>
+            <a:r>
+              <a:rPr sz="1920" b="1">
+                <a:solidFill>
+                  <a:srgbClr val="000000"/>
+                </a:solidFill>
+                <a:latin typeface="Times New Roman"/>
+                <a:ea typeface="Times New Roman"/>
+                <a:cs typeface="Times New Roman"/>
+              </a:rPr>
+              <a:t>● 四旋翼规划采用双积分近似时，FOV/距离约束对控制输入具有相对阶，需要高阶CBF。</a:t>
+            </a:r>
+          </a:p>
+          <a:p>
+            <a:pPr algn="l" marL="350000" indent="-120000">
+              <a:lnSpc>
+                <a:spcPct val="96000"/>
+              </a:lnSpc>
+              <a:spcBef>
+                <a:spcPts val="0"/>
+              </a:spcBef>
+              <a:spcAft>
+                <a:spcPts val="2"/>
+              </a:spcAft>
+            </a:pPr>
+            <a:r>
+              <a:rPr sz="1840" b="0">
+                <a:solidFill>
+                  <a:srgbClr val="000000"/>
+                </a:solidFill>
+                <a:latin typeface="Times New Roman"/>
+                <a:ea typeface="Times New Roman"/>
+                <a:cs typeface="Times New Roman"/>
+              </a:rPr>
+              <a:t>• HOCBF将安全集合前向不变性转化为控制输入u上的可检查不等式。</a:t>
+            </a:r>
+          </a:p>
+        </p:txBody>
+      </p:sp>
+      <p:sp>
+        <p:nvSpPr>
+          <p:cNvPr id="7" name="TextBox 6"/>
+          <p:cNvSpPr txBox="1"/>
+          <p:nvPr/>
+        </p:nvSpPr>
+        <p:spPr>
+          <a:xfrm>
+            <a:off x="841248" y="2432304"/>
+            <a:ext cx="10607040" cy="438912"/>
+          </a:xfrm>
+          <a:prstGeom prst="rect">
+            <a:avLst/>
+          </a:prstGeom>
+          <a:noFill/>
+        </p:spPr>
+        <p:txBody>
+          <a:bodyPr wrap="none" lIns="0" rIns="0" tIns="0" bIns="0">
+            <a:spAutoFit/>
+          </a:bodyPr>
+          <a:lstStyle/>
+          <a:p>
+            <a:pPr algn="l">
+              <a:lnSpc>
+                <a:spcPct val="100000"/>
+              </a:lnSpc>
+              <a:spcBef>
+                <a:spcPts val="0"/>
+              </a:spcBef>
+              <a:spcAft>
+                <a:spcPts val="0"/>
+              </a:spcAft>
+            </a:pPr>
+            <a:r>
+              <a:rPr sz="1939" b="1">
+                <a:solidFill>
+                  <a:srgbClr val="4E4E4E"/>
+                </a:solidFill>
+                <a:latin typeface="Times New Roman"/>
+                <a:ea typeface="Times New Roman"/>
+                <a:cs typeface="Times New Roman"/>
+              </a:rPr>
+              <a:t>(9)    L(f)^2 b(.) + L(g) L(f) b(.) u + (2μ+1)γ₁ b^(2μ)(.) L(f) b(.)</a:t>
+            </a:r>
+            <a:r>
+              <a:rPr sz="1939" b="0">
+                <a:solidFill>
+                  <a:srgbClr val="000000"/>
+                </a:solidFill>
+                <a:latin typeface="Times New Roman"/>
+                <a:ea typeface="Times New Roman"/>
+                <a:cs typeface="Times New Roman"/>
+              </a:rPr>
+              <a:t/>
+            </a:r>
+          </a:p>
+        </p:txBody>
+      </p:sp>
+      <p:sp>
+        <p:nvSpPr>
+          <p:cNvPr id="8" name="TextBox 7"/>
+          <p:cNvSpPr txBox="1"/>
+          <p:nvPr/>
+        </p:nvSpPr>
+        <p:spPr>
+          <a:xfrm>
+            <a:off x="841248" y="2944368"/>
+            <a:ext cx="10607040" cy="438912"/>
+          </a:xfrm>
+          <a:prstGeom prst="rect">
+            <a:avLst/>
+          </a:prstGeom>
+          <a:noFill/>
+        </p:spPr>
+        <p:txBody>
+          <a:bodyPr wrap="none" lIns="0" rIns="0" tIns="0" bIns="0">
+            <a:spAutoFit/>
+          </a:bodyPr>
+          <a:lstStyle/>
+          <a:p>
+            <a:pPr algn="l">
+              <a:lnSpc>
+                <a:spcPct val="100000"/>
+              </a:lnSpc>
+              <a:spcBef>
+                <a:spcPts val="0"/>
+              </a:spcBef>
+              <a:spcAft>
+                <a:spcPts val="0"/>
+              </a:spcAft>
+            </a:pPr>
+            <a:r>
+              <a:rPr sz="1939" b="1">
+                <a:solidFill>
+                  <a:srgbClr val="4E4E4E"/>
+                </a:solidFill>
+                <a:latin typeface="Times New Roman"/>
+                <a:ea typeface="Times New Roman"/>
+                <a:cs typeface="Times New Roman"/>
+              </a:rPr>
+              <a:t>    + γ₂( L(f) b(.) + γ₁ b^(2μ+1)(.) )^(2μ+1) &gt;= 0</a:t>
+            </a:r>
+            <a:r>
+              <a:rPr sz="1939" b="0">
+                <a:solidFill>
+                  <a:srgbClr val="000000"/>
+                </a:solidFill>
+                <a:latin typeface="Times New Roman"/>
+                <a:ea typeface="Times New Roman"/>
+                <a:cs typeface="Times New Roman"/>
+              </a:rPr>
+              <a:t/>
+            </a:r>
+          </a:p>
+        </p:txBody>
+      </p:sp>
+      <p:sp>
+        <p:nvSpPr>
+          <p:cNvPr id="9" name="Rectangle 8"/>
+          <p:cNvSpPr/>
+          <p:nvPr/>
+        </p:nvSpPr>
+        <p:spPr>
+          <a:xfrm>
+            <a:off x="694944" y="3712463"/>
+            <a:ext cx="10789920" cy="18288"/>
+          </a:xfrm>
+          <a:prstGeom prst="rect">
+            <a:avLst/>
+          </a:prstGeom>
+          <a:solidFill>
+            <a:srgbClr val="BEBEBE"/>
+          </a:solidFill>
+          <a:ln>
+            <a:noFill/>
+          </a:ln>
+        </p:spPr>
+        <p:style>
+          <a:lnRef idx="1">
+            <a:schemeClr val="accent1"/>
+          </a:lnRef>
+          <a:fillRef idx="3">
+            <a:schemeClr val="accent1"/>
+          </a:fillRef>
+          <a:effectRef idx="2">
+            <a:schemeClr val="accent1"/>
+          </a:effectRef>
+          <a:fontRef idx="minor">
+            <a:schemeClr val="lt1"/>
+          </a:fontRef>
+        </p:style>
+      </p:sp>
+      <p:sp>
+        <p:nvSpPr>
+          <p:cNvPr id="10" name="TextBox 9"/>
+          <p:cNvSpPr txBox="1"/>
+          <p:nvPr/>
+        </p:nvSpPr>
+        <p:spPr>
+          <a:xfrm>
+            <a:off x="676656" y="3931920"/>
+            <a:ext cx="5266944" cy="1664208"/>
+          </a:xfrm>
+          <a:prstGeom prst="rect">
+            <a:avLst/>
+          </a:prstGeom>
+          <a:noFill/>
+        </p:spPr>
+        <p:txBody>
+          <a:bodyPr wrap="square" lIns="0" rIns="0" tIns="0" bIns="0">
+            <a:spAutoFit/>
+          </a:bodyPr>
+          <a:lstStyle/>
+          <a:p>
             <a:pPr algn="l" marL="350000" indent="-120000">
               <a:lnSpc>
                 <a:spcPct val="92000"/>
@@ -12334,8 +12372,8 @@
         </p:nvSpPr>
         <p:spPr>
           <a:xfrm>
-            <a:off x="6272784" y="4334256"/>
-            <a:ext cx="5138928" cy="1517904"/>
+            <a:off x="6272784" y="3931920"/>
+            <a:ext cx="5138928" cy="1664208"/>
           </a:xfrm>
           <a:prstGeom prst="rect">
             <a:avLst/>

</xml_diff>